<commit_message>
Update recourse audit poster in PPTX format
</commit_message>
<xml_diff>
--- a/poster/recourse_audit_poster.pptx
+++ b/poster/recourse_audit_poster.pptx
@@ -5307,7 +5307,7 @@
         </p:nvSpPr>
         <p:spPr>
           <a:xfrm>
-            <a:off x="22494240" y="6309360"/>
+            <a:off x="22652992" y="5852160"/>
             <a:ext cx="4663440" cy="1143000"/>
           </a:xfrm>
           <a:prstGeom prst="rect">
@@ -5343,7 +5343,7 @@
         </p:nvSpPr>
         <p:spPr>
           <a:xfrm>
-            <a:off x="22494240" y="7498080"/>
+            <a:off x="22606000" y="7086600"/>
             <a:ext cx="4663440" cy="685800"/>
           </a:xfrm>
           <a:prstGeom prst="rect">
@@ -5379,7 +5379,7 @@
         </p:nvSpPr>
         <p:spPr>
           <a:xfrm>
-            <a:off x="27340560" y="6309360"/>
+            <a:off x="27499312" y="5852160"/>
             <a:ext cx="4663440" cy="1143000"/>
           </a:xfrm>
           <a:prstGeom prst="rect">
@@ -5415,7 +5415,7 @@
         </p:nvSpPr>
         <p:spPr>
           <a:xfrm>
-            <a:off x="27340560" y="7498080"/>
+            <a:off x="27452320" y="7086600"/>
             <a:ext cx="4663440" cy="457200"/>
           </a:xfrm>
           <a:prstGeom prst="rect">
@@ -5451,7 +5451,7 @@
         </p:nvSpPr>
         <p:spPr>
           <a:xfrm>
-            <a:off x="22494240" y="8412480"/>
+            <a:off x="22606000" y="8001000"/>
             <a:ext cx="9692640" cy="457200"/>
           </a:xfrm>
           <a:prstGeom prst="rect">
@@ -5486,13 +5486,13 @@
           <p:nvPr>
             <p:extLst>
               <p:ext uri="{D42A27DB-BD31-4B8C-83A1-F6EECF244321}">
-                <p14:modId xmlns:p14="http://schemas.microsoft.com/office/powerpoint/2010/main" val="1853051912"/>
+                <p14:modId xmlns:p14="http://schemas.microsoft.com/office/powerpoint/2010/main" val="2155017314"/>
               </p:ext>
             </p:extLst>
           </p:nvPr>
         </p:nvGraphicFramePr>
         <p:xfrm>
-          <a:off x="22494240" y="8869680"/>
+          <a:off x="22390100" y="8412480"/>
           <a:ext cx="9692640" cy="1965960"/>
         </p:xfrm>
         <a:graphic>
@@ -5503,47 +5503,13 @@
       </p:graphicFrame>
       <p:sp>
         <p:nvSpPr>
-          <p:cNvPr id="112" name="be older callout"/>
-          <p:cNvSpPr/>
-          <p:nvPr/>
-        </p:nvSpPr>
-        <p:spPr>
-          <a:xfrm>
-            <a:off x="22494240" y="10972800"/>
-            <a:ext cx="9692640" cy="1188720"/>
-          </a:xfrm>
-          <a:prstGeom prst="roundRect">
-            <a:avLst>
-              <a:gd name="adj" fmla="val 11538"/>
-            </a:avLst>
-          </a:prstGeom>
-          <a:solidFill>
-            <a:schemeClr val="bg1"/>
-          </a:solidFill>
-          <a:ln w="12700">
-            <a:solidFill>
-              <a:schemeClr val="bg1"/>
-            </a:solidFill>
-            <a:prstDash val="solid"/>
-          </a:ln>
-        </p:spPr>
-        <p:txBody>
-          <a:bodyPr/>
-          <a:lstStyle/>
-          <a:p>
-            <a:endParaRPr lang="en-US"/>
-          </a:p>
-        </p:txBody>
-      </p:sp>
-      <p:sp>
-        <p:nvSpPr>
           <p:cNvPr id="113" name="Text 108"/>
           <p:cNvSpPr txBox="1"/>
           <p:nvPr/>
         </p:nvSpPr>
         <p:spPr>
           <a:xfrm>
-            <a:off x="22768560" y="11064240"/>
+            <a:off x="22766020" y="10584180"/>
             <a:ext cx="9144000" cy="1005840"/>
           </a:xfrm>
           <a:prstGeom prst="rect">
@@ -5599,7 +5565,7 @@
         </p:nvSpPr>
         <p:spPr>
           <a:xfrm>
-            <a:off x="22494240" y="12573000"/>
+            <a:off x="22630130" y="11983212"/>
             <a:ext cx="731520" cy="731520"/>
           </a:xfrm>
           <a:prstGeom prst="ellipse">
@@ -5619,7 +5585,7 @@
           <a:bodyPr/>
           <a:lstStyle/>
           <a:p>
-            <a:endParaRPr lang="en-US"/>
+            <a:endParaRPr lang="en-US" dirty="0"/>
           </a:p>
         </p:txBody>
       </p:sp>
@@ -5631,7 +5597,7 @@
         </p:nvSpPr>
         <p:spPr>
           <a:xfrm>
-            <a:off x="22494240" y="12573000"/>
+            <a:off x="22630130" y="11983212"/>
             <a:ext cx="731520" cy="731520"/>
           </a:xfrm>
           <a:prstGeom prst="rect">
@@ -5667,7 +5633,7 @@
         </p:nvSpPr>
         <p:spPr>
           <a:xfrm>
-            <a:off x="23454360" y="12527280"/>
+            <a:off x="23590250" y="11937492"/>
             <a:ext cx="8732520" cy="1371600"/>
           </a:xfrm>
           <a:prstGeom prst="rect">
@@ -5707,13 +5673,13 @@
           <p:nvPr>
             <p:extLst>
               <p:ext uri="{D42A27DB-BD31-4B8C-83A1-F6EECF244321}">
-                <p14:modId xmlns:p14="http://schemas.microsoft.com/office/powerpoint/2010/main" val="1579011935"/>
+                <p14:modId xmlns:p14="http://schemas.microsoft.com/office/powerpoint/2010/main" val="1753832704"/>
               </p:ext>
             </p:extLst>
           </p:nvPr>
         </p:nvGraphicFramePr>
         <p:xfrm>
-          <a:off x="22494240" y="14081760"/>
+          <a:off x="22630130" y="13491972"/>
           <a:ext cx="8778240" cy="1508760"/>
         </p:xfrm>
         <a:graphic>
@@ -6388,7 +6354,7 @@
         </p:nvSpPr>
         <p:spPr>
           <a:xfrm>
-            <a:off x="22494240" y="15727680"/>
+            <a:off x="22630130" y="15137892"/>
             <a:ext cx="9692640" cy="731520"/>
           </a:xfrm>
           <a:prstGeom prst="rect">
@@ -6424,7 +6390,7 @@
         </p:nvSpPr>
         <p:spPr>
           <a:xfrm>
-            <a:off x="22494240" y="16596360"/>
+            <a:off x="22632734" y="15941509"/>
             <a:ext cx="731520" cy="731520"/>
           </a:xfrm>
           <a:prstGeom prst="ellipse">
@@ -6456,7 +6422,7 @@
         </p:nvSpPr>
         <p:spPr>
           <a:xfrm>
-            <a:off x="22494240" y="16596360"/>
+            <a:off x="22632734" y="15941509"/>
             <a:ext cx="731520" cy="731520"/>
           </a:xfrm>
           <a:prstGeom prst="rect">
@@ -6492,7 +6458,7 @@
         </p:nvSpPr>
         <p:spPr>
           <a:xfrm>
-            <a:off x="23454360" y="16550640"/>
+            <a:off x="23592854" y="15895789"/>
             <a:ext cx="8732520" cy="822960"/>
           </a:xfrm>
           <a:prstGeom prst="rect">
@@ -6531,7 +6497,7 @@
         </p:nvSpPr>
         <p:spPr>
           <a:xfrm>
-            <a:off x="22494240" y="17647920"/>
+            <a:off x="22632734" y="16993069"/>
             <a:ext cx="9692640" cy="1783080"/>
           </a:xfrm>
           <a:prstGeom prst="rect">
@@ -6988,7 +6954,7 @@
         </p:nvSpPr>
         <p:spPr>
           <a:xfrm>
-            <a:off x="22494240" y="19568160"/>
+            <a:off x="22632734" y="19042381"/>
             <a:ext cx="731520" cy="731520"/>
           </a:xfrm>
           <a:prstGeom prst="ellipse">
@@ -7020,7 +6986,7 @@
         </p:nvSpPr>
         <p:spPr>
           <a:xfrm>
-            <a:off x="22494240" y="19568160"/>
+            <a:off x="22632734" y="19042381"/>
             <a:ext cx="731520" cy="731520"/>
           </a:xfrm>
           <a:prstGeom prst="rect">
@@ -7056,7 +7022,7 @@
         </p:nvSpPr>
         <p:spPr>
           <a:xfrm>
-            <a:off x="23454360" y="19522439"/>
+            <a:off x="23592854" y="18996660"/>
             <a:ext cx="8732520" cy="822960"/>
           </a:xfrm>
           <a:prstGeom prst="rect">
@@ -7095,7 +7061,7 @@
         </p:nvSpPr>
         <p:spPr>
           <a:xfrm>
-            <a:off x="22494240" y="20482560"/>
+            <a:off x="22632734" y="19956781"/>
             <a:ext cx="9692640" cy="868680"/>
           </a:xfrm>
           <a:prstGeom prst="rect">

</xml_diff>

<commit_message>
Update recourse audit poster in PDF and PPTX formats
</commit_message>
<xml_diff>
--- a/poster/recourse_audit_poster.pptx
+++ b/poster/recourse_audit_poster.pptx
@@ -2632,7 +2632,7 @@
             </a:r>
             <a:r>
               <a:rPr lang="en-US" sz="2600" dirty="0" err="1"/>
-              <a:t>do.</a:t>
+              <a:t>do. </a:t>
             </a:r>
             <a:r>
               <a:rPr lang="en-US" sz="2600" dirty="0" err="1">
@@ -5551,7 +5551,7 @@
                   <a:schemeClr val="tx1"/>
                 </a:solidFill>
               </a:rPr>
-              <a:t>“be older” (median: be 4</a:t>
+              <a:t>“be older” (median: be 48)</a:t>
             </a:r>
             <a:endParaRPr lang="en-US" sz="2600" dirty="0"/>
           </a:p>

</xml_diff>